<commit_message>
Exec v7 wording precision
</commit_message>
<xml_diff>
--- a/audience-2026-10-22/LLA_Audience_Exec.pptx
+++ b/audience-2026-10-22/LLA_Audience_Exec.pptx
@@ -4164,7 +4164,7 @@
                 </a:solidFill>
                 <a:latin typeface="Poppins"/>
               </a:rPr>
-              <a:t>5,979 leads at $20. 4 online purchases; the rest close through sales.</a:t>
+              <a:t>5,979 leads at $20. 4 online purchases; sales-team closes sit in the CRM.</a:t>
             </a:r>
           </a:p>
           <a:p>
@@ -4289,7 +4289,7 @@
                 </a:solidFill>
                 <a:latin typeface="Poppins"/>
               </a:rPr>
-              <a:t>Texas, California and Florida give 44% of leads. Texas costs least, $19 a lead.</a:t>
+              <a:t>Texas, California, Florida: 44% of leads. Texas alone 26%, at $19 a lead.</a:t>
             </a:r>
           </a:p>
         </p:txBody>

</xml_diff>